<commit_message>
chore: update presentation and mosquitto db
</commit_message>
<xml_diff>
--- a/presentation/SmartScape_NexaCity5G_CodeSmokers_PRABUDDHA2026.pdf.pptx
+++ b/presentation/SmartScape_NexaCity5G_CodeSmokers_PRABUDDHA2026.pdf.pptx
@@ -324,7 +324,7 @@
             <a:fld id="{1D8BD707-D9CF-40AE-B4C6-C98DA3205C09}" type="datetimeFigureOut">
               <a:rPr lang="en-US" smtClean="0"/>
               <a:pPr/>
-              <a:t>4/15/2026</a:t>
+              <a:t>4/16/2026</a:t>
             </a:fld>
             <a:endParaRPr lang="en-US"/>
           </a:p>
@@ -489,7 +489,7 @@
             <a:fld id="{1D8BD707-D9CF-40AE-B4C6-C98DA3205C09}" type="datetimeFigureOut">
               <a:rPr lang="en-US" smtClean="0"/>
               <a:pPr/>
-              <a:t>4/15/2026</a:t>
+              <a:t>4/16/2026</a:t>
             </a:fld>
             <a:endParaRPr lang="en-US"/>
           </a:p>
@@ -664,7 +664,7 @@
             <a:fld id="{1D8BD707-D9CF-40AE-B4C6-C98DA3205C09}" type="datetimeFigureOut">
               <a:rPr lang="en-US" smtClean="0"/>
               <a:pPr/>
-              <a:t>4/15/2026</a:t>
+              <a:t>4/16/2026</a:t>
             </a:fld>
             <a:endParaRPr lang="en-US"/>
           </a:p>
@@ -829,7 +829,7 @@
             <a:fld id="{1D8BD707-D9CF-40AE-B4C6-C98DA3205C09}" type="datetimeFigureOut">
               <a:rPr lang="en-US" smtClean="0"/>
               <a:pPr/>
-              <a:t>4/15/2026</a:t>
+              <a:t>4/16/2026</a:t>
             </a:fld>
             <a:endParaRPr lang="en-US"/>
           </a:p>
@@ -1071,7 +1071,7 @@
             <a:fld id="{1D8BD707-D9CF-40AE-B4C6-C98DA3205C09}" type="datetimeFigureOut">
               <a:rPr lang="en-US" smtClean="0"/>
               <a:pPr/>
-              <a:t>4/15/2026</a:t>
+              <a:t>4/16/2026</a:t>
             </a:fld>
             <a:endParaRPr lang="en-US"/>
           </a:p>
@@ -1353,7 +1353,7 @@
             <a:fld id="{1D8BD707-D9CF-40AE-B4C6-C98DA3205C09}" type="datetimeFigureOut">
               <a:rPr lang="en-US" smtClean="0"/>
               <a:pPr/>
-              <a:t>4/15/2026</a:t>
+              <a:t>4/16/2026</a:t>
             </a:fld>
             <a:endParaRPr lang="en-US"/>
           </a:p>
@@ -1769,7 +1769,7 @@
             <a:fld id="{1D8BD707-D9CF-40AE-B4C6-C98DA3205C09}" type="datetimeFigureOut">
               <a:rPr lang="en-US" smtClean="0"/>
               <a:pPr/>
-              <a:t>4/15/2026</a:t>
+              <a:t>4/16/2026</a:t>
             </a:fld>
             <a:endParaRPr lang="en-US"/>
           </a:p>
@@ -1883,7 +1883,7 @@
             <a:fld id="{1D8BD707-D9CF-40AE-B4C6-C98DA3205C09}" type="datetimeFigureOut">
               <a:rPr lang="en-US" smtClean="0"/>
               <a:pPr/>
-              <a:t>4/15/2026</a:t>
+              <a:t>4/16/2026</a:t>
             </a:fld>
             <a:endParaRPr lang="en-US"/>
           </a:p>
@@ -1975,7 +1975,7 @@
             <a:fld id="{1D8BD707-D9CF-40AE-B4C6-C98DA3205C09}" type="datetimeFigureOut">
               <a:rPr lang="en-US" smtClean="0"/>
               <a:pPr/>
-              <a:t>4/15/2026</a:t>
+              <a:t>4/16/2026</a:t>
             </a:fld>
             <a:endParaRPr lang="en-US"/>
           </a:p>
@@ -2247,7 +2247,7 @@
             <a:fld id="{1D8BD707-D9CF-40AE-B4C6-C98DA3205C09}" type="datetimeFigureOut">
               <a:rPr lang="en-US" smtClean="0"/>
               <a:pPr/>
-              <a:t>4/15/2026</a:t>
+              <a:t>4/16/2026</a:t>
             </a:fld>
             <a:endParaRPr lang="en-US"/>
           </a:p>
@@ -2496,7 +2496,7 @@
             <a:fld id="{1D8BD707-D9CF-40AE-B4C6-C98DA3205C09}" type="datetimeFigureOut">
               <a:rPr lang="en-US" smtClean="0"/>
               <a:pPr/>
-              <a:t>4/15/2026</a:t>
+              <a:t>4/16/2026</a:t>
             </a:fld>
             <a:endParaRPr lang="en-US"/>
           </a:p>
@@ -2704,7 +2704,7 @@
             <a:fld id="{1D8BD707-D9CF-40AE-B4C6-C98DA3205C09}" type="datetimeFigureOut">
               <a:rPr lang="en-US" smtClean="0"/>
               <a:pPr/>
-              <a:t>4/15/2026</a:t>
+              <a:t>4/16/2026</a:t>
             </a:fld>
             <a:endParaRPr lang="en-US"/>
           </a:p>
@@ -3135,7 +3135,7 @@
         </p:nvSpPr>
         <p:spPr>
           <a:xfrm>
-            <a:off x="5855922" y="1813703"/>
+            <a:off x="6715230" y="2944742"/>
             <a:ext cx="3684622" cy="4234996"/>
           </a:xfrm>
           <a:custGeom>
@@ -3596,7 +3596,7 @@
         <p:spPr>
           <a:xfrm>
             <a:off x="433222" y="968832"/>
-            <a:ext cx="5181600" cy="923330"/>
+            <a:ext cx="10260178" cy="1754326"/>
           </a:xfrm>
           <a:prstGeom prst="rect">
             <a:avLst/>
@@ -3619,6 +3619,32 @@
                 <a:latin typeface="Ubuntu Mono Medium" panose="020B0309030602030204" pitchFamily="49" charset="0"/>
               </a:rPr>
               <a:t>NexaCity</a:t>
+            </a:r>
+            <a:r>
+              <a:rPr lang="en-IN" sz="5400" dirty="0">
+                <a:solidFill>
+                  <a:schemeClr val="accent1">
+                    <a:lumMod val="75000"/>
+                  </a:schemeClr>
+                </a:solidFill>
+                <a:latin typeface="Ubuntu Mono Medium" panose="020B0309030602030204" pitchFamily="49" charset="0"/>
+              </a:rPr>
+              <a:t>: </a:t>
+            </a:r>
+            <a:r>
+              <a:rPr lang="en-US" sz="5400" dirty="0"/>
+              <a:t>Real-Time Smart Urban Monitoring System</a:t>
+            </a:r>
+            <a:r>
+              <a:rPr lang="en-IN" sz="5400" dirty="0">
+                <a:solidFill>
+                  <a:schemeClr val="accent1">
+                    <a:lumMod val="75000"/>
+                  </a:schemeClr>
+                </a:solidFill>
+                <a:latin typeface="Ubuntu Mono Medium" panose="020B0309030602030204" pitchFamily="49" charset="0"/>
+              </a:rPr>
+              <a:t> </a:t>
             </a:r>
             <a:r>
               <a:rPr lang="en-IN" sz="5400" dirty="0">

</xml_diff>